<commit_message>
Plan next week with PLAN_WEEK; skip cancelled games
Sleeper's NFL state only advances on Tuesday, so on a Monday night
the agent was advising on a week that was already decided.

- lib/sleeper.ts: PLAN_WEEK=<n> overrides the live week in
  getNflState(), which every feature and ingest reads; unset keeps
  the live week
- lib/ingest/opponent.ts: skip cancelled games when loading game
  lines (Sleeper keeps them in the schedule, so a team appeared twice
  and the insert hit a unique constraint)
- Deck: Week 6 demo question; eval result stated as a range
- Cheat sheet, dev log, .env.example: the setting, the new question,
  and Sonnet's eval scores across four runs (9, 9, 6, 7 of 9)

Co-Authored-By: Claude Opus 5.5 <noreply@anthropic.com>
</commit_message>
<xml_diff>
--- a/docs/Fantasy-Agent-Presentation.pptx
+++ b/docs/Fantasy-Agent-Presentation.pptx
@@ -4,6 +4,9 @@
   <p:sldMasterIdLst>
     <p:sldMasterId id="2147483648" r:id="rId1"/>
   </p:sldMasterIdLst>
+  <p:notesMasterIdLst>
+    <p:notesMasterId r:id="rId8"/>
+  </p:notesMasterIdLst>
   <p:sldIdLst>
     <p:sldId id="256" r:id="rId2"/>
     <p:sldId id="257" r:id="rId3"/>
@@ -12,10 +15,7 @@
     <p:sldId id="260" r:id="rId6"/>
     <p:sldId id="261" r:id="rId7"/>
   </p:sldIdLst>
-  <p:notesMasterIdLst>
-    <p:notesMasterId r:id="rId8"/>
-  </p:notesMasterIdLst>
-  <p:sldSz cx="9144000" cy="5143500"/>
+  <p:sldSz cx="9144000" cy="5143500" type="screen16x9"/>
   <p:notesSz cx="5143500" cy="9144000"/>
   <p:defaultTextStyle>
     <a:lvl1pPr marL="0" algn="l" defTabSz="914400" rtl="0" eaLnBrk="1" latinLnBrk="0" hangingPunct="1">
@@ -112,24 +112,24 @@
   <p:extLst>
     <p:ext uri="{521415D9-36F7-43E2-AB2F-B90AF26B5E84}">
       <p14:sectionLst xmlns:p14="http://schemas.microsoft.com/office/powerpoint/2010/main">
-        <p14:section name="Problem" id="{e6c0696a-c4a7-a936-6dc7-5cb56de89cc5}">
+        <p14:section name="Problem" id="{E6C0696A-C4A7-A936-6DC7-5CB56DE89CC5}">
           <p14:sldIdLst>
             <p14:sldId id="256"/>
             <p14:sldId id="257"/>
           </p14:sldIdLst>
         </p14:section>
-        <p14:section name="Build" id="{5b31ef5b-4dfc-6d6e-7d02-7dcc3b77baf2}">
+        <p14:section name="Build" id="{5B31EF5B-4DFC-6D6E-7D02-7DCC3B77BAF2}">
           <p14:sldIdLst>
             <p14:sldId id="258"/>
             <p14:sldId id="259"/>
           </p14:sldIdLst>
         </p14:section>
-        <p14:section name="Demo" id="{d0979d34-1d5f-7fae-9bae-ed622a0d1c6b}">
+        <p14:section name="Demo" id="{D0979D34-1D5F-7FAE-9BAE-ED622A0D1C6B}">
           <p14:sldIdLst>
             <p14:sldId id="260"/>
           </p14:sldIdLst>
         </p14:section>
-        <p14:section name="Wrap-up" id="{c0a0bc7c-e9d6-a1bd-5da1-6761b94f5fdd}">
+        <p14:section name="Wrap-up" id="{C0A0BC7C-E9D6-A1BD-5DA1-6761B94F5FDD}">
           <p14:sldIdLst>
             <p14:sldId id="261"/>
           </p14:sldIdLst>
@@ -165,234 +165,10 @@
           <a:chExt cx="0" cy="0"/>
         </a:xfrm>
       </p:grpSpPr>
-      <p:sp>
-        <p:nvSpPr>
-          <p:cNvPr id="2" name="Header Placeholder 1"/>
-          <p:cNvSpPr>
-            <a:spLocks noGrp="1"/>
-          </p:cNvSpPr>
-          <p:nvPr>
-            <p:ph type="hdr" sz="quarter"/>
-          </p:nvPr>
-        </p:nvSpPr>
-        <p:spPr>
-          <a:xfrm>
-            <a:off x="0" y="0"/>
-            <a:ext cx="2971800" cy="458788"/>
-          </a:xfrm>
-          <a:prstGeom prst="rect">
-            <a:avLst/>
-          </a:prstGeom>
-        </p:spPr>
-        <p:txBody>
-          <a:bodyPr vert="horz" lIns="91440" tIns="45720" rIns="91440" bIns="45720" rtlCol="0"/>
-          <a:lstStyle>
-            <a:lvl1pPr algn="l">
-              <a:defRPr sz="1200"/>
-            </a:lvl1pPr>
-          </a:lstStyle>
-          <a:p>
-            <a:endParaRPr lang="en-US"/>
-          </a:p>
-        </p:txBody>
-      </p:sp>
-      <p:sp>
-        <p:nvSpPr>
-          <p:cNvPr id="3" name="Date Placeholder 2"/>
-          <p:cNvSpPr>
-            <a:spLocks noGrp="1"/>
-          </p:cNvSpPr>
-          <p:nvPr>
-            <p:ph type="dt" idx="1"/>
-          </p:nvPr>
-        </p:nvSpPr>
-        <p:spPr>
-          <a:xfrm>
-            <a:off x="3884613" y="0"/>
-            <a:ext cx="2971800" cy="458788"/>
-          </a:xfrm>
-          <a:prstGeom prst="rect">
-            <a:avLst/>
-          </a:prstGeom>
-        </p:spPr>
-        <p:txBody>
-          <a:bodyPr vert="horz" lIns="91440" tIns="45720" rIns="91440" bIns="45720" rtlCol="0"/>
-          <a:lstStyle>
-            <a:lvl1pPr algn="r">
-              <a:defRPr sz="1200"/>
-            </a:lvl1pPr>
-          </a:lstStyle>
-          <a:p>
-            <a:fld id="{5282F153-3F37-0F45-9E97-73ACFA13230C}" type="datetimeFigureOut">
-              <a:rPr lang="en-US"/>
-              <a:t>7/23/19</a:t>
-            </a:fld>
-            <a:endParaRPr lang="en-US"/>
-          </a:p>
-        </p:txBody>
-      </p:sp>
-      <p:sp>
-        <p:nvSpPr>
-          <p:cNvPr id="4" name="Slide Image Placeholder 3"/>
-          <p:cNvSpPr>
-            <a:spLocks noGrp="1" noRot="1" noChangeAspect="1"/>
-          </p:cNvSpPr>
-          <p:nvPr>
-            <p:ph type="sldImg" idx="2"/>
-          </p:nvPr>
-        </p:nvSpPr>
-        <p:spPr>
-          <a:xfrm>
-            <a:off x="685800" y="1143000"/>
-            <a:ext cx="5486400" cy="3086100"/>
-          </a:xfrm>
-          <a:prstGeom prst="rect">
-            <a:avLst/>
-          </a:prstGeom>
-          <a:noFill/>
-          <a:ln w="12700">
-            <a:solidFill>
-              <a:prstClr val="black"/>
-            </a:solidFill>
-          </a:ln>
-        </p:spPr>
-        <p:txBody>
-          <a:bodyPr vert="horz" lIns="91440" tIns="45720" rIns="91440" bIns="45720" rtlCol="0" anchor="ctr"/>
-          <a:lstStyle/>
-          <a:p>
-            <a:endParaRPr lang="en-US"/>
-          </a:p>
-        </p:txBody>
-      </p:sp>
-      <p:sp>
-        <p:nvSpPr>
-          <p:cNvPr id="5" name="Notes Placeholder 4"/>
-          <p:cNvSpPr>
-            <a:spLocks noGrp="1"/>
-          </p:cNvSpPr>
-          <p:nvPr>
-            <p:ph type="body" sz="quarter" idx="3"/>
-          </p:nvPr>
-        </p:nvSpPr>
-        <p:spPr>
-          <a:xfrm>
-            <a:off x="685800" y="4400550"/>
-            <a:ext cx="5486400" cy="3600450"/>
-          </a:xfrm>
-          <a:prstGeom prst="rect">
-            <a:avLst/>
-          </a:prstGeom>
-        </p:spPr>
-        <p:txBody>
-          <a:bodyPr vert="horz" lIns="91440" tIns="45720" rIns="91440" bIns="45720" rtlCol="0"/>
-          <a:lstStyle/>
-          <a:p>
-            <a:pPr lvl="0"/>
-            <a:r>
-              <a:rPr lang="en-US"/>
-              <a:t>Click to edit Master text styles</a:t>
-            </a:r>
-          </a:p>
-          <a:p>
-            <a:pPr lvl="1"/>
-            <a:r>
-              <a:rPr lang="en-US"/>
-              <a:t>Second level</a:t>
-            </a:r>
-          </a:p>
-          <a:p>
-            <a:pPr lvl="2"/>
-            <a:r>
-              <a:rPr lang="en-US"/>
-              <a:t>Third level</a:t>
-            </a:r>
-          </a:p>
-          <a:p>
-            <a:pPr lvl="3"/>
-            <a:r>
-              <a:rPr lang="en-US"/>
-              <a:t>Fourth level</a:t>
-            </a:r>
-          </a:p>
-          <a:p>
-            <a:pPr lvl="4"/>
-            <a:r>
-              <a:rPr lang="en-US"/>
-              <a:t>Fifth level</a:t>
-            </a:r>
-          </a:p>
-        </p:txBody>
-      </p:sp>
-      <p:sp>
-        <p:nvSpPr>
-          <p:cNvPr id="6" name="Footer Placeholder 5"/>
-          <p:cNvSpPr>
-            <a:spLocks noGrp="1"/>
-          </p:cNvSpPr>
-          <p:nvPr>
-            <p:ph type="ftr" sz="quarter" idx="4"/>
-          </p:nvPr>
-        </p:nvSpPr>
-        <p:spPr>
-          <a:xfrm>
-            <a:off x="0" y="8685213"/>
-            <a:ext cx="2971800" cy="458787"/>
-          </a:xfrm>
-          <a:prstGeom prst="rect">
-            <a:avLst/>
-          </a:prstGeom>
-        </p:spPr>
-        <p:txBody>
-          <a:bodyPr vert="horz" lIns="91440" tIns="45720" rIns="91440" bIns="45720" rtlCol="0" anchor="b"/>
-          <a:lstStyle>
-            <a:lvl1pPr algn="l">
-              <a:defRPr sz="1200"/>
-            </a:lvl1pPr>
-          </a:lstStyle>
-          <a:p>
-            <a:endParaRPr lang="en-US"/>
-          </a:p>
-        </p:txBody>
-      </p:sp>
-      <p:sp>
-        <p:nvSpPr>
-          <p:cNvPr id="7" name="Slide Number Placeholder 6"/>
-          <p:cNvSpPr>
-            <a:spLocks noGrp="1"/>
-          </p:cNvSpPr>
-          <p:nvPr>
-            <p:ph type="sldNum" sz="quarter" idx="5"/>
-          </p:nvPr>
-        </p:nvSpPr>
-        <p:spPr>
-          <a:xfrm>
-            <a:off x="3884613" y="8685213"/>
-            <a:ext cx="2971800" cy="458787"/>
-          </a:xfrm>
-          <a:prstGeom prst="rect">
-            <a:avLst/>
-          </a:prstGeom>
-        </p:spPr>
-        <p:txBody>
-          <a:bodyPr vert="horz" lIns="91440" tIns="45720" rIns="91440" bIns="45720" rtlCol="0" anchor="b"/>
-          <a:lstStyle>
-            <a:lvl1pPr algn="r">
-              <a:defRPr sz="1200"/>
-            </a:lvl1pPr>
-          </a:lstStyle>
-          <a:p>
-            <a:fld id="{CE5E9CC1-C706-0F49-92D6-E571CC5EEA8F}" type="slidenum">
-              <a:rPr lang="en-US"/>
-              <a:t>‹#›</a:t>
-            </a:fld>
-            <a:endParaRPr lang="en-US"/>
-          </a:p>
-        </p:txBody>
-      </p:sp>
     </p:spTree>
     <p:extLst>
       <p:ext uri="{BB962C8B-B14F-4D97-AF65-F5344CB8AC3E}">
-        <p14:creationId xmlns:p14="http://schemas.microsoft.com/office/powerpoint/2010/main" val="1024086991"/>
+        <p14:creationId xmlns:p14="http://schemas.microsoft.com/office/powerpoint/2010/main" val="2730478477"/>
       </p:ext>
     </p:extLst>
   </p:cSld>
@@ -540,7 +316,6 @@
               <a:rPr lang="en-US" dirty="0"/>
               <a:t>[0:10] Name and project, then straight to the problem slide. Have the terminal already open with the command typed.</a:t>
             </a:r>
-            <a:endParaRPr lang="en-US" dirty="0"/>
           </a:p>
         </p:txBody>
       </p:sp>
@@ -628,7 +403,6 @@
               <a:rPr lang="en-US" dirty="0"/>
               <a:t>[0:20] Say the bold sentence, nothing more. The six sources: Sleeper, three other projection sites (ESPN, CBS, FFToday), FantasyCalc trade values, Vegas lines, plus YouTube analysts for news.</a:t>
             </a:r>
-            <a:endParaRPr lang="en-US" dirty="0"/>
           </a:p>
         </p:txBody>
       </p:sp>
@@ -716,7 +490,6 @@
               <a:rPr lang="en-US" dirty="0"/>
               <a:t>[0:50] Left: the loop is about 150 lines in lib/agent/loop.ts, using the Anthropic SDK directly. Step 2 is the only place the model acts. Tools run in parallel; an error goes back to the model as a result, so it can correct itself. Right: I built and backtested the bottom two layers first with no AI, then wrapped nine features as tools. Point at the files: fetch = lib/ingest, decide = loop.ts.</a:t>
             </a:r>
-            <a:endParaRPr lang="en-US" dirty="0"/>
           </a:p>
         </p:txBody>
       </p:sp>
@@ -804,7 +577,6 @@
               <a:rPr lang="en-US" dirty="0"/>
               <a:t>[0:40] This is the question the professor is most likely to ask. Left column has one right answer each, so it is code. Right column is judgment. Say the script answer out loud: the weekly plan is scriptable and I built it that way first (lib/agent/advisor.ts, still in the repo). Swap the AI for rules and a fixed weekly check barely changes; what you lose is open questions, branching on results (example: it checked WR waivers on its own after RB and TE were not upgrades), and recovering from a wrong league name.</a:t>
             </a:r>
-            <a:endParaRPr lang="en-US" dirty="0"/>
           </a:p>
         </p:txBody>
       </p:sp>
@@ -890,9 +662,8 @@
           <a:p>
             <a:r>
               <a:rPr lang="en-US" dirty="0"/>
-              <a:t>[2:00] Switch to the terminal and press Enter. Narrate: turn 1 lists my leagues; turn 2 asks for the matchup in all three leagues at once; then it picks the worst one and goes deeper there. Point out any turn where it changes course. End on the answer, the turn/tool/token counts, and the line where it says it can't make the moves for me. If it breaks, say so and show the saved backup run or screenshots. Oct 11 run for reference (Sonnet 5): 7 turns, 10 tool calls, 34 seconds.</a:t>
-            </a:r>
-            <a:endParaRPr lang="en-US" dirty="0"/>
+              <a:t>[2:00] Switch to the terminal and press Enter. Narrate: turn 1 lists my leagues; turn 2 asks for the matchup in all three leagues at once; then it picks the worst one and goes deeper there. Point out any turn where it changes course. End on the answer, the turn/tool/token counts, and the line where it says it can't make the moves for me. If it breaks, say so and show the saved backup run or screenshots. First, in this terminal: PLAN_WEEK is set to 6, because Sleeper only moves to the next week on Tuesday. Oct 12 dry run (Sonnet 5): 6 turns, 7 tool calls, 25 seconds; it picked Escalated Calls at 51% to win, found 6.5 points on the bench, and noticed the starting defense was on bye.</a:t>
+            </a:r>
           </a:p>
         </p:txBody>
       </p:sp>
@@ -978,9 +749,8 @@
           <a:p>
             <a:r>
               <a:rPr lang="en-US" dirty="0"/>
-              <a:t>[0:30] Pick one item per column. Evals: 9 fixed questions scored by code checks plus a second model (Opus 5) as judge. On Oct 11 I tried the cheapest model, Haiku 4.5: it looped fine and was about 2.5x faster, but passed only 4 of 9. It invented details no tool returned (a $15 bid, "9 to 11 weeks remaining", an injury for a player), read a rank backwards, and did not say it can't place a waiver claim. Sonnet 5 passed 9 of 9 on the same day, so the choice of model is a tested decision. Stale data: one run had no projections loaded for the week; the tools returned zeros and the agent declined to recommend moves. The backtest also removed a matchup tiebreaker that made start/sit calls worse. Close: the repo is on GitHub with a README that says how to run it.</a:t>
-            </a:r>
-            <a:endParaRPr lang="en-US" dirty="0"/>
+              <a:t>[0:30] Pick one item per column. Evals: 9 fixed questions scored by code checks plus a second model (Opus 5) as judge. On Oct 11 I tried the cheapest model, Haiku 4.5: it looped fine and was about 2.5x faster, but passed only 4 of 9. It invented details no tool returned (a $15 bid, "9 to 11 weeks remaining", an injury for a player), read a rank backwards, and did not say it can't place a waiver claim. Sonnet 5 scored 9, 9, 6 and 7 of 9 across four runs, so it is clearly better, but one run is not a reliable score: the failures are small ungrounded phrases and they move between cases. Next step is running each case several times and reporting a pass rate. Stale data: one run had no projections loaded for the week; the tools returned zeros and the agent declined to recommend moves. The backtest also removed a matchup tiebreaker that made start/sit calls worse. Close: the repo is on GitHub with a README that says how to run it.</a:t>
+            </a:r>
           </a:p>
         </p:txBody>
       </p:sp>
@@ -1058,6 +828,7 @@
         <a:solidFill>
           <a:srgbClr val="14532D"/>
         </a:solidFill>
+        <a:effectLst/>
       </p:bgPr>
     </p:bg>
     <p:spTree>
@@ -1077,9 +848,11 @@
       <p:sp>
         <p:nvSpPr>
           <p:cNvPr id="2" name="Text 0"/>
-          <p:cNvSpPr/>
+          <p:cNvSpPr>
+            <a:spLocks noGrp="1"/>
+          </p:cNvSpPr>
           <p:nvPr>
-            <p:ph idx="100" type="title" hasCustomPrompt="1"/>
+            <p:ph type="title" idx="100" hasCustomPrompt="1"/>
           </p:nvPr>
         </p:nvSpPr>
         <p:spPr>
@@ -1096,7 +869,7 @@
         <p:txBody>
           <a:bodyPr wrap="square" rtlCol="0"/>
           <a:lstStyle>
-            <a:lvl1pPr algn="l" indent="0" marL="0">
+            <a:lvl1pPr marL="0" indent="0" algn="l">
               <a:buNone/>
               <a:defRPr lang="en-US" sz="4400" b="1" dirty="0">
                 <a:solidFill>
@@ -1106,7 +879,7 @@
             </a:lvl1pPr>
           </a:lstStyle>
           <a:p>
-            <a:pPr algn="l" indent="0" marL="0">
+            <a:pPr marL="0" indent="0" algn="l">
               <a:buNone/>
             </a:pPr>
             <a:endParaRPr lang="en-US" sz="4400" dirty="0"/>
@@ -1116,9 +889,11 @@
       <p:sp>
         <p:nvSpPr>
           <p:cNvPr id="3" name="Text 0"/>
-          <p:cNvSpPr/>
+          <p:cNvSpPr>
+            <a:spLocks noGrp="1"/>
+          </p:cNvSpPr>
           <p:nvPr>
-            <p:ph idx="101" type="body" hasCustomPrompt="1"/>
+            <p:ph type="body" idx="101" hasCustomPrompt="1"/>
           </p:nvPr>
         </p:nvSpPr>
         <p:spPr>
@@ -1135,7 +910,7 @@
         <p:txBody>
           <a:bodyPr wrap="square" rtlCol="0"/>
           <a:lstStyle>
-            <a:lvl1pPr algn="l" indent="0" marL="0">
+            <a:lvl1pPr marL="0" indent="0" algn="l">
               <a:buNone/>
               <a:defRPr lang="en-US" sz="2000" dirty="0">
                 <a:solidFill>
@@ -1145,7 +920,7 @@
             </a:lvl1pPr>
           </a:lstStyle>
           <a:p>
-            <a:pPr algn="l" indent="0" marL="0">
+            <a:pPr marL="0" indent="0" algn="l">
               <a:buNone/>
             </a:pPr>
             <a:endParaRPr lang="en-US" sz="2000" dirty="0"/>
@@ -1168,6 +943,7 @@
         <a:solidFill>
           <a:srgbClr val="FFFFFF"/>
         </a:solidFill>
+        <a:effectLst/>
       </p:bgPr>
     </p:bg>
     <p:spTree>
@@ -1187,9 +963,11 @@
       <p:sp>
         <p:nvSpPr>
           <p:cNvPr id="2" name="Text 0"/>
-          <p:cNvSpPr/>
+          <p:cNvSpPr>
+            <a:spLocks noGrp="1"/>
+          </p:cNvSpPr>
           <p:nvPr>
-            <p:ph idx="100" type="title" hasCustomPrompt="1"/>
+            <p:ph type="title" idx="100" hasCustomPrompt="1"/>
           </p:nvPr>
         </p:nvSpPr>
         <p:spPr>
@@ -1206,7 +984,7 @@
         <p:txBody>
           <a:bodyPr wrap="square" rtlCol="0"/>
           <a:lstStyle>
-            <a:lvl1pPr algn="l" indent="0" marL="0">
+            <a:lvl1pPr marL="0" indent="0" algn="l">
               <a:buNone/>
               <a:defRPr lang="en-US" sz="3000" b="1" dirty="0">
                 <a:solidFill>
@@ -1216,7 +994,7 @@
             </a:lvl1pPr>
           </a:lstStyle>
           <a:p>
-            <a:pPr algn="l" indent="0" marL="0">
+            <a:pPr marL="0" indent="0" algn="l">
               <a:buNone/>
             </a:pPr>
             <a:endParaRPr lang="en-US" sz="3000" dirty="0"/>
@@ -1243,7 +1021,7 @@
           </a:prstGeom>
           <a:extLst>
             <a:ext uri="{C572A759-6A51-4108-AA02-DFA0A04FC94B}">
-              <ma14:wrappingTextBoxFlag xmlns:ma14="http://schemas.microsoft.com/office/mac/drawingml/2011/main" val="0"/>
+              <ma14:wrappingTextBoxFlag xmlns:ma14="http://schemas.microsoft.com/office/mac/drawingml/2011/main" xmlns="" val="0"/>
             </a:ext>
           </a:extLst>
         </p:spPr>
@@ -1261,8 +1039,8 @@
           <a:p>
             <a:pPr algn="r"/>
             <a:fld id="{F7021451-1387-4CA6-816F-3879F97B5CBC}" type="slidenum">
-              <a:rPr b="0" lang="en-US"/>
-              <a:t>1003</a:t>
+              <a:rPr lang="en-US" b="0"/>
+              <a:t>‹#›</a:t>
             </a:fld>
             <a:endParaRPr lang="en-US"/>
           </a:p>
@@ -1284,6 +1062,7 @@
         <a:solidFill>
           <a:srgbClr val="14532D"/>
         </a:solidFill>
+        <a:effectLst/>
       </p:bgPr>
     </p:bg>
     <p:spTree>
@@ -1303,9 +1082,11 @@
       <p:sp>
         <p:nvSpPr>
           <p:cNvPr id="2" name="Text 0"/>
-          <p:cNvSpPr/>
+          <p:cNvSpPr>
+            <a:spLocks noGrp="1"/>
+          </p:cNvSpPr>
           <p:nvPr>
-            <p:ph idx="100" type="title" hasCustomPrompt="1"/>
+            <p:ph type="title" idx="100" hasCustomPrompt="1"/>
           </p:nvPr>
         </p:nvSpPr>
         <p:spPr>
@@ -1322,7 +1103,7 @@
         <p:txBody>
           <a:bodyPr wrap="square" rtlCol="0"/>
           <a:lstStyle>
-            <a:lvl1pPr algn="l" indent="0" marL="0">
+            <a:lvl1pPr marL="0" indent="0" algn="l">
               <a:buNone/>
               <a:defRPr lang="en-US" sz="3000" b="1" dirty="0">
                 <a:solidFill>
@@ -1332,7 +1113,7 @@
             </a:lvl1pPr>
           </a:lstStyle>
           <a:p>
-            <a:pPr algn="l" indent="0" marL="0">
+            <a:pPr marL="0" indent="0" algn="l">
               <a:buNone/>
             </a:pPr>
             <a:endParaRPr lang="en-US" sz="3000" dirty="0"/>
@@ -1359,7 +1140,7 @@
           </a:prstGeom>
           <a:extLst>
             <a:ext uri="{C572A759-6A51-4108-AA02-DFA0A04FC94B}">
-              <ma14:wrappingTextBoxFlag xmlns:ma14="http://schemas.microsoft.com/office/mac/drawingml/2011/main" val="0"/>
+              <ma14:wrappingTextBoxFlag xmlns:ma14="http://schemas.microsoft.com/office/mac/drawingml/2011/main" xmlns="" val="0"/>
             </a:ext>
           </a:extLst>
         </p:spPr>
@@ -1377,8 +1158,8 @@
           <a:p>
             <a:pPr algn="r"/>
             <a:fld id="{F7021451-1387-4CA6-816F-3879F97B5CBC}" type="slidenum">
-              <a:rPr b="0" lang="en-US"/>
-              <a:t>1004</a:t>
+              <a:rPr lang="en-US" b="0"/>
+              <a:t>‹#›</a:t>
             </a:fld>
             <a:endParaRPr lang="en-US"/>
           </a:p>
@@ -1395,6 +1176,11 @@
 <file path=ppt/slideMasters/slideMaster1.xml><?xml version="1.0" encoding="utf-8"?>
 <p:sldMaster xmlns:a="http://schemas.openxmlformats.org/drawingml/2006/main" xmlns:r="http://schemas.openxmlformats.org/officeDocument/2006/relationships" xmlns:p="http://schemas.openxmlformats.org/presentationml/2006/main">
   <p:cSld>
+    <p:bg>
+      <p:bgRef idx="1001">
+        <a:schemeClr val="bg1"/>
+      </p:bgRef>
+    </p:bg>
     <p:spTree>
       <p:nvGrpSpPr>
         <p:cNvPr id="1" name=""/>
@@ -1429,7 +1215,7 @@
           </a:prstGeom>
           <a:extLst>
             <a:ext uri="{C572A759-6A51-4108-AA02-DFA0A04FC94B}">
-              <ma14:wrappingTextBoxFlag xmlns:ma14="http://schemas.microsoft.com/office/mac/drawingml/2011/main" val="0"/>
+              <ma14:wrappingTextBoxFlag xmlns:ma14="http://schemas.microsoft.com/office/mac/drawingml/2011/main" xmlns="" val="0"/>
             </a:ext>
           </a:extLst>
         </p:spPr>
@@ -1447,8 +1233,8 @@
           <a:p>
             <a:pPr algn="r"/>
             <a:fld id="{F7021451-1387-4CA6-816F-3879F97B5CBC}" type="slidenum">
-              <a:rPr b="0" lang="en-US"/>
-              <a:t>null</a:t>
+              <a:rPr lang="en-US" b="0"/>
+              <a:t>‹#›</a:t>
             </a:fld>
             <a:endParaRPr lang="en-US"/>
           </a:p>
@@ -1758,6 +1544,13 @@
             <a:prstDash val="solid"/>
           </a:ln>
         </p:spPr>
+        <p:txBody>
+          <a:bodyPr/>
+          <a:lstStyle/>
+          <a:p>
+            <a:endParaRPr lang="en-US"/>
+          </a:p>
+        </p:txBody>
       </p:sp>
       <p:sp>
         <p:nvSpPr>
@@ -1780,16 +1573,16 @@
           <a:bodyPr wrap="square" lIns="0" tIns="0" rIns="0" bIns="0" rtlCol="0" anchor="ctr"/>
           <a:lstStyle/>
           <a:p>
-            <a:pPr indent="0" marL="0">
-              <a:buNone/>
-            </a:pPr>
-            <a:r>
-              <a:rPr lang="en-US" sz="1200" b="1" spc="200" kern="0" dirty="0">
+            <a:pPr marL="0" indent="0">
+              <a:buNone/>
+            </a:pPr>
+            <a:r>
+              <a:rPr lang="en-US" sz="1200" b="1" kern="0" spc="200" dirty="0">
                 <a:solidFill>
                   <a:schemeClr val="accent5"/>
                 </a:solidFill>
               </a:rPr>
-              <a:t>MINI-PROJECT  ·  BUAN 6V99</a:t>
+              <a:t>MINI-PROJECT  ·  BUAN 6V99 – Agentic AI</a:t>
             </a:r>
             <a:endParaRPr lang="en-US" sz="1200" dirty="0"/>
           </a:p>
@@ -1798,9 +1591,11 @@
       <p:sp>
         <p:nvSpPr>
           <p:cNvPr id="4" name="Text 0"/>
-          <p:cNvSpPr/>
+          <p:cNvSpPr>
+            <a:spLocks noGrp="1"/>
+          </p:cNvSpPr>
           <p:nvPr>
-            <p:ph idx="100" type="title" hasCustomPrompt="1"/>
+            <p:ph type="title" idx="100" hasCustomPrompt="1"/>
           </p:nvPr>
         </p:nvSpPr>
         <p:spPr>
@@ -1818,7 +1613,7 @@
           <a:bodyPr wrap="square" lIns="0" tIns="0" rIns="0" bIns="0" rtlCol="0" anchor="b"/>
           <a:lstStyle/>
           <a:p>
-            <a:pPr algn="l" indent="0" marL="0">
+            <a:pPr marL="0" indent="0" algn="l">
               <a:buNone/>
             </a:pPr>
             <a:r>
@@ -1836,9 +1631,11 @@
       <p:sp>
         <p:nvSpPr>
           <p:cNvPr id="5" name="Text 0"/>
-          <p:cNvSpPr/>
+          <p:cNvSpPr>
+            <a:spLocks noGrp="1"/>
+          </p:cNvSpPr>
           <p:nvPr>
-            <p:ph idx="101" type="body" hasCustomPrompt="1"/>
+            <p:ph type="body" idx="101" hasCustomPrompt="1"/>
           </p:nvPr>
         </p:nvSpPr>
         <p:spPr>
@@ -1856,7 +1653,7 @@
           <a:bodyPr wrap="square" lIns="0" tIns="0" rIns="0" bIns="0" rtlCol="0" anchor="t"/>
           <a:lstStyle/>
           <a:p>
-            <a:pPr algn="l" indent="0" marL="0">
+            <a:pPr marL="0" indent="0" algn="l">
               <a:buNone/>
             </a:pPr>
             <a:r>
@@ -1892,7 +1689,7 @@
           <a:bodyPr wrap="square" lIns="0" tIns="0" rIns="0" bIns="0" rtlCol="0" anchor="ctr"/>
           <a:lstStyle/>
           <a:p>
-            <a:pPr indent="0" marL="0">
+            <a:pPr marL="0" indent="0">
               <a:buNone/>
             </a:pPr>
             <a:r>
@@ -1901,7 +1698,7 @@
                   <a:schemeClr val="accent5"/>
                 </a:solidFill>
               </a:rPr>
-              <a:t>Alex  ·  October 12, 2026</a:t>
+              <a:t>Alex Miller  ·  October 12, 2026</a:t>
             </a:r>
             <a:endParaRPr lang="en-US" sz="1400" dirty="0"/>
           </a:p>
@@ -1935,9 +1732,11 @@
       <p:sp>
         <p:nvSpPr>
           <p:cNvPr id="2" name="Text 0"/>
-          <p:cNvSpPr/>
+          <p:cNvSpPr>
+            <a:spLocks noGrp="1"/>
+          </p:cNvSpPr>
           <p:nvPr>
-            <p:ph idx="100" type="title" hasCustomPrompt="1"/>
+            <p:ph type="title" idx="100" hasCustomPrompt="1"/>
           </p:nvPr>
         </p:nvSpPr>
         <p:spPr>
@@ -1955,7 +1754,7 @@
           <a:bodyPr wrap="square" lIns="0" tIns="0" rIns="0" bIns="0" rtlCol="0" anchor="ctr"/>
           <a:lstStyle/>
           <a:p>
-            <a:pPr algn="l" indent="0" marL="0">
+            <a:pPr marL="0" indent="0" algn="l">
               <a:buNone/>
             </a:pPr>
             <a:r>
@@ -1991,7 +1790,7 @@
           <a:bodyPr wrap="square" lIns="0" tIns="0" rIns="0" bIns="0" rtlCol="0" anchor="t"/>
           <a:lstStyle/>
           <a:p>
-            <a:pPr indent="0" marL="0">
+            <a:pPr marL="0" indent="0">
               <a:spcAft>
                 <a:spcPts val="1200"/>
               </a:spcAft>
@@ -2003,12 +1802,12 @@
                   <a:schemeClr val="tx1"/>
                 </a:solidFill>
               </a:rPr>
-              <a:t>I manage teams in three fantasy leagues, and every week I was leaving points on my bench and overpaying on waivers.</a:t>
+              <a:t>I manage teams in several fantasy leagues, and every week I was spending too much time trying to make roster decisions.</a:t>
             </a:r>
             <a:endParaRPr lang="en-US" sz="1600" dirty="0"/>
           </a:p>
           <a:p>
-            <a:pPr indent="0" marL="0">
+            <a:pPr marL="0" indent="0">
               <a:buNone/>
             </a:pPr>
             <a:r>
@@ -2017,7 +1816,7 @@
                   <a:schemeClr val="tx1"/>
                 </a:solidFill>
               </a:rPr>
-              <a:t>Each league needs a lineup, a waiver bid and a look at trades. The numbers behind those calls sit on four projection sites, a trade-value market, Vegas lines and each league's own bidding history.</a:t>
+              <a:t>Each league needs a lineup, waiver bids and a look at trades. The numbers behind those calls sit on four projection sites, a trade-value market, Vegas lines and each league's own bidding history.</a:t>
             </a:r>
             <a:endParaRPr lang="en-US" sz="1600" dirty="0"/>
           </a:p>
@@ -2049,6 +1848,13 @@
             <a:prstDash val="solid"/>
           </a:ln>
         </p:spPr>
+        <p:txBody>
+          <a:bodyPr/>
+          <a:lstStyle/>
+          <a:p>
+            <a:endParaRPr lang="en-US"/>
+          </a:p>
+        </p:txBody>
       </p:sp>
       <p:sp>
         <p:nvSpPr>
@@ -2071,7 +1877,7 @@
           <a:bodyPr wrap="square" lIns="0" tIns="0" rIns="0" bIns="0" rtlCol="0" anchor="ctr"/>
           <a:lstStyle/>
           <a:p>
-            <a:pPr algn="ctr" indent="0" marL="0">
+            <a:pPr marL="0" indent="0" algn="ctr">
               <a:buNone/>
             </a:pPr>
             <a:r>
@@ -2107,7 +1913,7 @@
           <a:bodyPr wrap="square" lIns="0" tIns="0" rIns="0" bIns="0" rtlCol="0" anchor="ctr"/>
           <a:lstStyle/>
           <a:p>
-            <a:pPr indent="0" marL="0">
+            <a:pPr marL="0" indent="0">
               <a:buNone/>
             </a:pPr>
             <a:r>
@@ -2148,6 +1954,13 @@
             <a:prstDash val="solid"/>
           </a:ln>
         </p:spPr>
+        <p:txBody>
+          <a:bodyPr/>
+          <a:lstStyle/>
+          <a:p>
+            <a:endParaRPr lang="en-US"/>
+          </a:p>
+        </p:txBody>
       </p:sp>
       <p:sp>
         <p:nvSpPr>
@@ -2170,7 +1983,7 @@
           <a:bodyPr wrap="square" lIns="0" tIns="0" rIns="0" bIns="0" rtlCol="0" anchor="ctr"/>
           <a:lstStyle/>
           <a:p>
-            <a:pPr algn="ctr" indent="0" marL="0">
+            <a:pPr marL="0" indent="0" algn="ctr">
               <a:buNone/>
             </a:pPr>
             <a:r>
@@ -2206,7 +2019,7 @@
           <a:bodyPr wrap="square" lIns="0" tIns="0" rIns="0" bIns="0" rtlCol="0" anchor="ctr"/>
           <a:lstStyle/>
           <a:p>
-            <a:pPr indent="0" marL="0">
+            <a:pPr marL="0" indent="0">
               <a:buNone/>
             </a:pPr>
             <a:r>
@@ -2247,6 +2060,13 @@
             <a:prstDash val="solid"/>
           </a:ln>
         </p:spPr>
+        <p:txBody>
+          <a:bodyPr/>
+          <a:lstStyle/>
+          <a:p>
+            <a:endParaRPr lang="en-US"/>
+          </a:p>
+        </p:txBody>
       </p:sp>
       <p:sp>
         <p:nvSpPr>
@@ -2269,7 +2089,7 @@
           <a:bodyPr wrap="square" lIns="0" tIns="0" rIns="0" bIns="0" rtlCol="0" anchor="ctr"/>
           <a:lstStyle/>
           <a:p>
-            <a:pPr algn="ctr" indent="0" marL="0">
+            <a:pPr marL="0" indent="0" algn="ctr">
               <a:buNone/>
             </a:pPr>
             <a:r>
@@ -2305,7 +2125,7 @@
           <a:bodyPr wrap="square" lIns="0" tIns="0" rIns="0" bIns="0" rtlCol="0" anchor="ctr"/>
           <a:lstStyle/>
           <a:p>
-            <a:pPr indent="0" marL="0">
+            <a:pPr marL="0" indent="0">
               <a:buNone/>
             </a:pPr>
             <a:r>
@@ -2340,7 +2160,7 @@
           </a:prstGeom>
           <a:extLst>
             <a:ext uri="{C572A759-6A51-4108-AA02-DFA0A04FC94B}">
-              <ma14:wrappingTextBoxFlag xmlns:ma14="http://schemas.microsoft.com/office/mac/drawingml/2011/main" val="0"/>
+              <ma14:wrappingTextBoxFlag xmlns:ma14="http://schemas.microsoft.com/office/mac/drawingml/2011/main" xmlns="" val="0"/>
             </a:ext>
           </a:extLst>
         </p:spPr>
@@ -2358,7 +2178,7 @@
           <a:p>
             <a:pPr algn="r"/>
             <a:fld id="{F7021451-1387-4CA6-816F-3879F97B5CBC}" type="slidenum">
-              <a:rPr b="0" lang="en-US"/>
+              <a:rPr lang="en-US" b="0"/>
               <a:t>2</a:t>
             </a:fld>
             <a:endParaRPr lang="en-US"/>
@@ -2393,9 +2213,11 @@
       <p:sp>
         <p:nvSpPr>
           <p:cNvPr id="2" name="Text 0"/>
-          <p:cNvSpPr/>
+          <p:cNvSpPr>
+            <a:spLocks noGrp="1"/>
+          </p:cNvSpPr>
           <p:nvPr>
-            <p:ph idx="100" type="title" hasCustomPrompt="1"/>
+            <p:ph type="title" idx="100" hasCustomPrompt="1"/>
           </p:nvPr>
         </p:nvSpPr>
         <p:spPr>
@@ -2413,7 +2235,7 @@
           <a:bodyPr wrap="square" lIns="0" tIns="0" rIns="0" bIns="0" rtlCol="0" anchor="ctr"/>
           <a:lstStyle/>
           <a:p>
-            <a:pPr algn="l" indent="0" marL="0">
+            <a:pPr marL="0" indent="0" algn="l">
               <a:buNone/>
             </a:pPr>
             <a:r>
@@ -2454,6 +2276,13 @@
             <a:prstDash val="solid"/>
           </a:ln>
         </p:spPr>
+        <p:txBody>
+          <a:bodyPr/>
+          <a:lstStyle/>
+          <a:p>
+            <a:endParaRPr lang="en-US"/>
+          </a:p>
+        </p:txBody>
       </p:sp>
       <p:sp>
         <p:nvSpPr>
@@ -2479,6 +2308,13 @@
             <a:prstDash val="solid"/>
           </a:ln>
         </p:spPr>
+        <p:txBody>
+          <a:bodyPr/>
+          <a:lstStyle/>
+          <a:p>
+            <a:endParaRPr lang="en-US"/>
+          </a:p>
+        </p:txBody>
       </p:sp>
       <p:sp>
         <p:nvSpPr>
@@ -2501,7 +2337,7 @@
           <a:bodyPr wrap="square" lIns="0" tIns="0" rIns="0" bIns="0" rtlCol="0" anchor="ctr"/>
           <a:lstStyle/>
           <a:p>
-            <a:pPr algn="ctr" indent="0" marL="0">
+            <a:pPr marL="0" indent="0" algn="ctr">
               <a:buNone/>
             </a:pPr>
             <a:r>
@@ -2537,7 +2373,7 @@
           <a:bodyPr wrap="square" lIns="0" tIns="0" rIns="0" bIns="0" rtlCol="0" anchor="ctr"/>
           <a:lstStyle/>
           <a:p>
-            <a:pPr indent="0" marL="0">
+            <a:pPr marL="0" indent="0">
               <a:buNone/>
             </a:pPr>
             <a:r>
@@ -2578,6 +2414,13 @@
             <a:prstDash val="solid"/>
           </a:ln>
         </p:spPr>
+        <p:txBody>
+          <a:bodyPr/>
+          <a:lstStyle/>
+          <a:p>
+            <a:endParaRPr lang="en-US"/>
+          </a:p>
+        </p:txBody>
       </p:sp>
       <p:sp>
         <p:nvSpPr>
@@ -2603,6 +2446,13 @@
             <a:prstDash val="solid"/>
           </a:ln>
         </p:spPr>
+        <p:txBody>
+          <a:bodyPr/>
+          <a:lstStyle/>
+          <a:p>
+            <a:endParaRPr lang="en-US"/>
+          </a:p>
+        </p:txBody>
       </p:sp>
       <p:sp>
         <p:nvSpPr>
@@ -2625,7 +2475,7 @@
           <a:bodyPr wrap="square" lIns="0" tIns="0" rIns="0" bIns="0" rtlCol="0" anchor="ctr"/>
           <a:lstStyle/>
           <a:p>
-            <a:pPr algn="ctr" indent="0" marL="0">
+            <a:pPr marL="0" indent="0" algn="ctr">
               <a:buNone/>
             </a:pPr>
             <a:r>
@@ -2661,7 +2511,7 @@
           <a:bodyPr wrap="square" lIns="0" tIns="0" rIns="0" bIns="0" rtlCol="0" anchor="ctr"/>
           <a:lstStyle/>
           <a:p>
-            <a:pPr indent="0" marL="0">
+            <a:pPr marL="0" indent="0">
               <a:buNone/>
             </a:pPr>
             <a:r>
@@ -2702,6 +2552,13 @@
             <a:prstDash val="solid"/>
           </a:ln>
         </p:spPr>
+        <p:txBody>
+          <a:bodyPr/>
+          <a:lstStyle/>
+          <a:p>
+            <a:endParaRPr lang="en-US"/>
+          </a:p>
+        </p:txBody>
       </p:sp>
       <p:sp>
         <p:nvSpPr>
@@ -2727,6 +2584,13 @@
             <a:prstDash val="solid"/>
           </a:ln>
         </p:spPr>
+        <p:txBody>
+          <a:bodyPr/>
+          <a:lstStyle/>
+          <a:p>
+            <a:endParaRPr lang="en-US"/>
+          </a:p>
+        </p:txBody>
       </p:sp>
       <p:sp>
         <p:nvSpPr>
@@ -2749,7 +2613,7 @@
           <a:bodyPr wrap="square" lIns="0" tIns="0" rIns="0" bIns="0" rtlCol="0" anchor="ctr"/>
           <a:lstStyle/>
           <a:p>
-            <a:pPr algn="ctr" indent="0" marL="0">
+            <a:pPr marL="0" indent="0" algn="ctr">
               <a:buNone/>
             </a:pPr>
             <a:r>
@@ -2785,7 +2649,7 @@
           <a:bodyPr wrap="square" lIns="0" tIns="0" rIns="0" bIns="0" rtlCol="0" anchor="ctr"/>
           <a:lstStyle/>
           <a:p>
-            <a:pPr indent="0" marL="0">
+            <a:pPr marL="0" indent="0">
               <a:buNone/>
             </a:pPr>
             <a:r>
@@ -2826,6 +2690,13 @@
             <a:prstDash val="solid"/>
           </a:ln>
         </p:spPr>
+        <p:txBody>
+          <a:bodyPr/>
+          <a:lstStyle/>
+          <a:p>
+            <a:endParaRPr lang="en-US"/>
+          </a:p>
+        </p:txBody>
       </p:sp>
       <p:sp>
         <p:nvSpPr>
@@ -2851,6 +2722,13 @@
             <a:prstDash val="solid"/>
           </a:ln>
         </p:spPr>
+        <p:txBody>
+          <a:bodyPr/>
+          <a:lstStyle/>
+          <a:p>
+            <a:endParaRPr lang="en-US"/>
+          </a:p>
+        </p:txBody>
       </p:sp>
       <p:sp>
         <p:nvSpPr>
@@ -2873,7 +2751,7 @@
           <a:bodyPr wrap="square" lIns="0" tIns="0" rIns="0" bIns="0" rtlCol="0" anchor="ctr"/>
           <a:lstStyle/>
           <a:p>
-            <a:pPr algn="ctr" indent="0" marL="0">
+            <a:pPr marL="0" indent="0" algn="ctr">
               <a:buNone/>
             </a:pPr>
             <a:r>
@@ -2909,7 +2787,7 @@
           <a:bodyPr wrap="square" lIns="0" tIns="0" rIns="0" bIns="0" rtlCol="0" anchor="ctr"/>
           <a:lstStyle/>
           <a:p>
-            <a:pPr indent="0" marL="0">
+            <a:pPr marL="0" indent="0">
               <a:buNone/>
             </a:pPr>
             <a:r>
@@ -2947,6 +2825,13 @@
             <a:tailEnd type="triangle"/>
           </a:ln>
         </p:spPr>
+        <p:txBody>
+          <a:bodyPr/>
+          <a:lstStyle/>
+          <a:p>
+            <a:endParaRPr lang="en-US"/>
+          </a:p>
+        </p:txBody>
       </p:sp>
       <p:sp>
         <p:nvSpPr>
@@ -2971,6 +2856,13 @@
             <a:tailEnd type="triangle"/>
           </a:ln>
         </p:spPr>
+        <p:txBody>
+          <a:bodyPr/>
+          <a:lstStyle/>
+          <a:p>
+            <a:endParaRPr lang="en-US"/>
+          </a:p>
+        </p:txBody>
       </p:sp>
       <p:sp>
         <p:nvSpPr>
@@ -2995,6 +2887,13 @@
             <a:headEnd type="triangle"/>
           </a:ln>
         </p:spPr>
+        <p:txBody>
+          <a:bodyPr/>
+          <a:lstStyle/>
+          <a:p>
+            <a:endParaRPr lang="en-US"/>
+          </a:p>
+        </p:txBody>
       </p:sp>
       <p:sp>
         <p:nvSpPr>
@@ -3019,6 +2918,13 @@
             <a:headEnd type="triangle"/>
           </a:ln>
         </p:spPr>
+        <p:txBody>
+          <a:bodyPr/>
+          <a:lstStyle/>
+          <a:p>
+            <a:endParaRPr lang="en-US"/>
+          </a:p>
+        </p:txBody>
       </p:sp>
       <p:sp>
         <p:nvSpPr>
@@ -3041,7 +2947,7 @@
           <a:bodyPr wrap="square" lIns="0" tIns="0" rIns="0" bIns="0" rtlCol="0" anchor="t"/>
           <a:lstStyle/>
           <a:p>
-            <a:pPr indent="0" marL="0">
+            <a:pPr marL="0" indent="0">
               <a:buNone/>
             </a:pPr>
             <a:r>
@@ -3082,6 +2988,13 @@
             <a:prstDash val="solid"/>
           </a:ln>
         </p:spPr>
+        <p:txBody>
+          <a:bodyPr/>
+          <a:lstStyle/>
+          <a:p>
+            <a:endParaRPr lang="en-US"/>
+          </a:p>
+        </p:txBody>
       </p:sp>
       <p:sp>
         <p:nvSpPr>
@@ -3104,7 +3017,7 @@
           <a:bodyPr wrap="square" lIns="0" tIns="0" rIns="0" bIns="0" rtlCol="0" anchor="ctr"/>
           <a:lstStyle/>
           <a:p>
-            <a:pPr indent="0" marL="0">
+            <a:pPr marL="0" indent="0">
               <a:buNone/>
             </a:pPr>
             <a:r>
@@ -3115,9 +3028,6 @@
               </a:rPr>
               <a:t>Fetch</a:t>
             </a:r>
-            <a:pPr indent="0" marL="0">
-              <a:buNone/>
-            </a:pPr>
             <a:r>
               <a:rPr lang="en-US" sz="1200" dirty="0">
                 <a:solidFill>
@@ -3132,7 +3042,7 @@
             <a:endParaRPr lang="en-US" sz="1600" dirty="0"/>
           </a:p>
           <a:p>
-            <a:pPr indent="0" marL="0">
+            <a:pPr marL="0" indent="0">
               <a:buNone/>
             </a:pPr>
             <a:r>
@@ -3173,6 +3083,13 @@
             <a:prstDash val="solid"/>
           </a:ln>
         </p:spPr>
+        <p:txBody>
+          <a:bodyPr/>
+          <a:lstStyle/>
+          <a:p>
+            <a:endParaRPr lang="en-US"/>
+          </a:p>
+        </p:txBody>
       </p:sp>
       <p:sp>
         <p:nvSpPr>
@@ -3195,7 +3112,7 @@
           <a:bodyPr wrap="square" lIns="0" tIns="0" rIns="0" bIns="0" rtlCol="0" anchor="ctr"/>
           <a:lstStyle/>
           <a:p>
-            <a:pPr indent="0" marL="0">
+            <a:pPr marL="0" indent="0">
               <a:buNone/>
             </a:pPr>
             <a:r>
@@ -3206,9 +3123,6 @@
               </a:rPr>
               <a:t>Compute</a:t>
             </a:r>
-            <a:pPr indent="0" marL="0">
-              <a:buNone/>
-            </a:pPr>
             <a:r>
               <a:rPr lang="en-US" sz="1200" dirty="0">
                 <a:solidFill>
@@ -3223,7 +3137,7 @@
             <a:endParaRPr lang="en-US" sz="1600" dirty="0"/>
           </a:p>
           <a:p>
-            <a:pPr indent="0" marL="0">
+            <a:pPr marL="0" indent="0">
               <a:buNone/>
             </a:pPr>
             <a:r>
@@ -3264,6 +3178,13 @@
             <a:prstDash val="solid"/>
           </a:ln>
         </p:spPr>
+        <p:txBody>
+          <a:bodyPr/>
+          <a:lstStyle/>
+          <a:p>
+            <a:endParaRPr lang="en-US"/>
+          </a:p>
+        </p:txBody>
       </p:sp>
       <p:sp>
         <p:nvSpPr>
@@ -3286,7 +3207,7 @@
           <a:bodyPr wrap="square" lIns="0" tIns="0" rIns="0" bIns="0" rtlCol="0" anchor="ctr"/>
           <a:lstStyle/>
           <a:p>
-            <a:pPr indent="0" marL="0">
+            <a:pPr marL="0" indent="0">
               <a:buNone/>
             </a:pPr>
             <a:r>
@@ -3297,9 +3218,6 @@
               </a:rPr>
               <a:t>Decide</a:t>
             </a:r>
-            <a:pPr indent="0" marL="0">
-              <a:buNone/>
-            </a:pPr>
             <a:r>
               <a:rPr lang="en-US" sz="1200" dirty="0">
                 <a:solidFill>
@@ -3314,7 +3232,7 @@
             <a:endParaRPr lang="en-US" sz="1600" dirty="0"/>
           </a:p>
           <a:p>
-            <a:pPr indent="0" marL="0">
+            <a:pPr marL="0" indent="0">
               <a:buNone/>
             </a:pPr>
             <a:r>
@@ -3331,7 +3249,7 @@
       </p:sp>
       <p:sp>
         <p:nvSpPr>
-          <p:cNvPr id="25" name="Slide Number Placeholder 0"/>
+          <p:cNvPr id="30" name="Slide Number Placeholder 0"/>
           <p:cNvSpPr>
             <a:spLocks noGrp="1"/>
           </p:cNvSpPr>
@@ -3349,7 +3267,7 @@
           </a:prstGeom>
           <a:extLst>
             <a:ext uri="{C572A759-6A51-4108-AA02-DFA0A04FC94B}">
-              <ma14:wrappingTextBoxFlag xmlns:ma14="http://schemas.microsoft.com/office/mac/drawingml/2011/main" val="0"/>
+              <ma14:wrappingTextBoxFlag xmlns:ma14="http://schemas.microsoft.com/office/mac/drawingml/2011/main" xmlns="" val="0"/>
             </a:ext>
           </a:extLst>
         </p:spPr>
@@ -3367,7 +3285,7 @@
           <a:p>
             <a:pPr algn="r"/>
             <a:fld id="{F7021451-1387-4CA6-816F-3879F97B5CBC}" type="slidenum">
-              <a:rPr b="0" lang="en-US"/>
+              <a:rPr lang="en-US" b="0"/>
               <a:t>3</a:t>
             </a:fld>
             <a:endParaRPr lang="en-US"/>
@@ -3402,9 +3320,11 @@
       <p:sp>
         <p:nvSpPr>
           <p:cNvPr id="2" name="Text 0"/>
-          <p:cNvSpPr/>
+          <p:cNvSpPr>
+            <a:spLocks noGrp="1"/>
+          </p:cNvSpPr>
           <p:nvPr>
-            <p:ph idx="100" type="title" hasCustomPrompt="1"/>
+            <p:ph type="title" idx="100" hasCustomPrompt="1"/>
           </p:nvPr>
         </p:nvSpPr>
         <p:spPr>
@@ -3422,7 +3342,7 @@
           <a:bodyPr wrap="square" lIns="0" tIns="0" rIns="0" bIns="0" rtlCol="0" anchor="ctr"/>
           <a:lstStyle/>
           <a:p>
-            <a:pPr algn="l" indent="0" marL="0">
+            <a:pPr marL="0" indent="0" algn="l">
               <a:buNone/>
             </a:pPr>
             <a:r>
@@ -3463,6 +3383,13 @@
             <a:prstDash val="solid"/>
           </a:ln>
         </p:spPr>
+        <p:txBody>
+          <a:bodyPr/>
+          <a:lstStyle/>
+          <a:p>
+            <a:endParaRPr lang="en-US"/>
+          </a:p>
+        </p:txBody>
       </p:sp>
       <p:sp>
         <p:nvSpPr>
@@ -3485,7 +3412,7 @@
           <a:bodyPr wrap="square" lIns="0" tIns="0" rIns="0" bIns="0" rtlCol="0" anchor="ctr"/>
           <a:lstStyle/>
           <a:p>
-            <a:pPr indent="0" marL="0">
+            <a:pPr marL="0" indent="0">
               <a:buNone/>
             </a:pPr>
             <a:r>
@@ -3620,6 +3547,13 @@
             <a:prstDash val="solid"/>
           </a:ln>
         </p:spPr>
+        <p:txBody>
+          <a:bodyPr/>
+          <a:lstStyle/>
+          <a:p>
+            <a:endParaRPr lang="en-US"/>
+          </a:p>
+        </p:txBody>
       </p:sp>
       <p:sp>
         <p:nvSpPr>
@@ -3642,7 +3576,7 @@
           <a:bodyPr wrap="square" lIns="0" tIns="0" rIns="0" bIns="0" rtlCol="0" anchor="ctr"/>
           <a:lstStyle/>
           <a:p>
-            <a:pPr indent="0" marL="0">
+            <a:pPr marL="0" indent="0">
               <a:buNone/>
             </a:pPr>
             <a:r>
@@ -3772,7 +3706,7 @@
           <a:bodyPr wrap="square" lIns="0" tIns="0" rIns="0" bIns="0" rtlCol="0" anchor="t"/>
           <a:lstStyle/>
           <a:p>
-            <a:pPr indent="0" marL="0">
+            <a:pPr marL="0" indent="0">
               <a:buNone/>
             </a:pPr>
             <a:r>
@@ -3783,9 +3717,6 @@
               </a:rPr>
               <a:t>Could I write every step down in advance?  </a:t>
             </a:r>
-            <a:pPr indent="0" marL="0">
-              <a:buNone/>
-            </a:pPr>
             <a:r>
               <a:rPr lang="en-US" sz="1400" dirty="0">
                 <a:solidFill>
@@ -3818,7 +3749,7 @@
           </a:prstGeom>
           <a:extLst>
             <a:ext uri="{C572A759-6A51-4108-AA02-DFA0A04FC94B}">
-              <ma14:wrappingTextBoxFlag xmlns:ma14="http://schemas.microsoft.com/office/mac/drawingml/2011/main" val="0"/>
+              <ma14:wrappingTextBoxFlag xmlns:ma14="http://schemas.microsoft.com/office/mac/drawingml/2011/main" xmlns="" val="0"/>
             </a:ext>
           </a:extLst>
         </p:spPr>
@@ -3836,7 +3767,7 @@
           <a:p>
             <a:pPr algn="r"/>
             <a:fld id="{F7021451-1387-4CA6-816F-3879F97B5CBC}" type="slidenum">
-              <a:rPr b="0" lang="en-US"/>
+              <a:rPr lang="en-US" b="0"/>
               <a:t>4</a:t>
             </a:fld>
             <a:endParaRPr lang="en-US"/>
@@ -3871,9 +3802,11 @@
       <p:sp>
         <p:nvSpPr>
           <p:cNvPr id="2" name="Text 0"/>
-          <p:cNvSpPr/>
+          <p:cNvSpPr>
+            <a:spLocks noGrp="1"/>
+          </p:cNvSpPr>
           <p:nvPr>
-            <p:ph idx="100" type="title" hasCustomPrompt="1"/>
+            <p:ph type="title" idx="100" hasCustomPrompt="1"/>
           </p:nvPr>
         </p:nvSpPr>
         <p:spPr>
@@ -3891,7 +3824,7 @@
           <a:bodyPr wrap="square" lIns="0" tIns="0" rIns="0" bIns="0" rtlCol="0" anchor="ctr"/>
           <a:lstStyle/>
           <a:p>
-            <a:pPr algn="l" indent="0" marL="0">
+            <a:pPr marL="0" indent="0" algn="l">
               <a:buNone/>
             </a:pPr>
             <a:r>
@@ -3932,6 +3865,13 @@
             <a:prstDash val="solid"/>
           </a:ln>
         </p:spPr>
+        <p:txBody>
+          <a:bodyPr/>
+          <a:lstStyle/>
+          <a:p>
+            <a:endParaRPr lang="en-US"/>
+          </a:p>
+        </p:txBody>
       </p:sp>
       <p:sp>
         <p:nvSpPr>
@@ -3954,7 +3894,7 @@
           <a:bodyPr wrap="square" lIns="0" tIns="0" rIns="0" bIns="0" rtlCol="0" anchor="ctr"/>
           <a:lstStyle/>
           <a:p>
-            <a:pPr indent="0" marL="0">
+            <a:pPr marL="0" indent="0">
               <a:buNone/>
             </a:pPr>
             <a:r>
@@ -3963,7 +3903,7 @@
                   <a:schemeClr val="bg1"/>
                 </a:solidFill>
               </a:rPr>
-              <a:t>“Find the league where I'm in the most trouble this week. Then fix it: set my best lineup, find a waiver pickup for my weakest starting spot with a bid and who to drop, and check the news on anyone you recommend.”</a:t>
+              <a:t>“Week 5 is almost over, so get me ready for Week 6. Find the league where I'm in the most trouble next week. Then fix it: set my best lineup, find a waiver pickup for my weakest starting spot with a bid and who to drop, and check the news on anyone you recommend.”</a:t>
             </a:r>
             <a:endParaRPr lang="en-US" sz="1600" dirty="0"/>
           </a:p>
@@ -3990,7 +3930,7 @@
           <a:bodyPr wrap="square" lIns="0" tIns="0" rIns="0" bIns="0" rtlCol="0" anchor="ctr"/>
           <a:lstStyle/>
           <a:p>
-            <a:pPr indent="0" marL="0">
+            <a:pPr marL="0" indent="0">
               <a:buNone/>
             </a:pPr>
             <a:r>
@@ -4032,6 +3972,13 @@
             <a:prstDash val="solid"/>
           </a:ln>
         </p:spPr>
+        <p:txBody>
+          <a:bodyPr/>
+          <a:lstStyle/>
+          <a:p>
+            <a:endParaRPr lang="en-US"/>
+          </a:p>
+        </p:txBody>
       </p:sp>
       <p:sp>
         <p:nvSpPr>
@@ -4054,7 +4001,7 @@
           <a:bodyPr wrap="square" lIns="0" tIns="0" rIns="0" bIns="0" rtlCol="0" anchor="ctr"/>
           <a:lstStyle/>
           <a:p>
-            <a:pPr algn="ctr" indent="0" marL="0">
+            <a:pPr marL="0" indent="0" algn="ctr">
               <a:buNone/>
             </a:pPr>
             <a:r>
@@ -4090,7 +4037,7 @@
           <a:bodyPr wrap="square" lIns="0" tIns="0" rIns="0" bIns="0" rtlCol="0" anchor="ctr"/>
           <a:lstStyle/>
           <a:p>
-            <a:pPr indent="0" marL="0">
+            <a:pPr marL="0" indent="0">
               <a:buNone/>
             </a:pPr>
             <a:r>
@@ -4104,7 +4051,7 @@
             <a:endParaRPr lang="en-US" sz="1600" dirty="0"/>
           </a:p>
           <a:p>
-            <a:pPr indent="0" marL="0">
+            <a:pPr marL="0" indent="0">
               <a:buNone/>
             </a:pPr>
             <a:r>
@@ -4143,6 +4090,13 @@
             <a:prstDash val="solid"/>
           </a:ln>
         </p:spPr>
+        <p:txBody>
+          <a:bodyPr/>
+          <a:lstStyle/>
+          <a:p>
+            <a:endParaRPr lang="en-US"/>
+          </a:p>
+        </p:txBody>
       </p:sp>
       <p:sp>
         <p:nvSpPr>
@@ -4165,7 +4119,7 @@
           <a:bodyPr wrap="square" lIns="0" tIns="0" rIns="0" bIns="0" rtlCol="0" anchor="ctr"/>
           <a:lstStyle/>
           <a:p>
-            <a:pPr algn="ctr" indent="0" marL="0">
+            <a:pPr marL="0" indent="0" algn="ctr">
               <a:buNone/>
             </a:pPr>
             <a:r>
@@ -4201,7 +4155,7 @@
           <a:bodyPr wrap="square" lIns="0" tIns="0" rIns="0" bIns="0" rtlCol="0" anchor="ctr"/>
           <a:lstStyle/>
           <a:p>
-            <a:pPr indent="0" marL="0">
+            <a:pPr marL="0" indent="0">
               <a:buNone/>
             </a:pPr>
             <a:r>
@@ -4215,7 +4169,7 @@
             <a:endParaRPr lang="en-US" sz="1600" dirty="0"/>
           </a:p>
           <a:p>
-            <a:pPr indent="0" marL="0">
+            <a:pPr marL="0" indent="0">
               <a:buNone/>
             </a:pPr>
             <a:r>
@@ -4254,6 +4208,13 @@
             <a:prstDash val="solid"/>
           </a:ln>
         </p:spPr>
+        <p:txBody>
+          <a:bodyPr/>
+          <a:lstStyle/>
+          <a:p>
+            <a:endParaRPr lang="en-US"/>
+          </a:p>
+        </p:txBody>
       </p:sp>
       <p:sp>
         <p:nvSpPr>
@@ -4276,7 +4237,7 @@
           <a:bodyPr wrap="square" lIns="0" tIns="0" rIns="0" bIns="0" rtlCol="0" anchor="ctr"/>
           <a:lstStyle/>
           <a:p>
-            <a:pPr algn="ctr" indent="0" marL="0">
+            <a:pPr marL="0" indent="0" algn="ctr">
               <a:buNone/>
             </a:pPr>
             <a:r>
@@ -4312,7 +4273,7 @@
           <a:bodyPr wrap="square" lIns="0" tIns="0" rIns="0" bIns="0" rtlCol="0" anchor="ctr"/>
           <a:lstStyle/>
           <a:p>
-            <a:pPr indent="0" marL="0">
+            <a:pPr marL="0" indent="0">
               <a:buNone/>
             </a:pPr>
             <a:r>
@@ -4326,7 +4287,7 @@
             <a:endParaRPr lang="en-US" sz="1600" dirty="0"/>
           </a:p>
           <a:p>
-            <a:pPr indent="0" marL="0">
+            <a:pPr marL="0" indent="0">
               <a:buNone/>
             </a:pPr>
             <a:r>
@@ -4362,7 +4323,7 @@
           <a:bodyPr wrap="square" lIns="0" tIns="0" rIns="0" bIns="0" rtlCol="0" anchor="ctr"/>
           <a:lstStyle/>
           <a:p>
-            <a:pPr indent="0" marL="0">
+            <a:pPr marL="0" indent="0">
               <a:buNone/>
             </a:pPr>
             <a:r>
@@ -4371,7 +4332,7 @@
                   <a:schemeClr val="accent5"/>
                 </a:solidFill>
               </a:rPr>
-              <a:t>About 35 seconds, 5 to 7 turns. Nobody programmed the sequence, and it changes from run to run.</a:t>
+              <a:t>About 25 seconds, 5 to 7 turns. Nobody programmed the sequence, and it changes from run to run.</a:t>
             </a:r>
             <a:endParaRPr lang="en-US" sz="1400" dirty="0"/>
           </a:p>
@@ -4397,7 +4358,7 @@
           </a:prstGeom>
           <a:extLst>
             <a:ext uri="{C572A759-6A51-4108-AA02-DFA0A04FC94B}">
-              <ma14:wrappingTextBoxFlag xmlns:ma14="http://schemas.microsoft.com/office/mac/drawingml/2011/main" val="0"/>
+              <ma14:wrappingTextBoxFlag xmlns:ma14="http://schemas.microsoft.com/office/mac/drawingml/2011/main" xmlns="" val="0"/>
             </a:ext>
           </a:extLst>
         </p:spPr>
@@ -4415,7 +4376,7 @@
           <a:p>
             <a:pPr algn="r"/>
             <a:fld id="{F7021451-1387-4CA6-816F-3879F97B5CBC}" type="slidenum">
-              <a:rPr b="0" lang="en-US"/>
+              <a:rPr lang="en-US" b="0"/>
               <a:t>5</a:t>
             </a:fld>
             <a:endParaRPr lang="en-US"/>
@@ -4450,9 +4411,11 @@
       <p:sp>
         <p:nvSpPr>
           <p:cNvPr id="2" name="Text 0"/>
-          <p:cNvSpPr/>
+          <p:cNvSpPr>
+            <a:spLocks noGrp="1"/>
+          </p:cNvSpPr>
           <p:nvPr>
-            <p:ph idx="100" type="title" hasCustomPrompt="1"/>
+            <p:ph type="title" idx="100" hasCustomPrompt="1"/>
           </p:nvPr>
         </p:nvSpPr>
         <p:spPr>
@@ -4470,7 +4433,7 @@
           <a:bodyPr wrap="square" lIns="0" tIns="0" rIns="0" bIns="0" rtlCol="0" anchor="ctr"/>
           <a:lstStyle/>
           <a:p>
-            <a:pPr algn="l" indent="0" marL="0">
+            <a:pPr marL="0" indent="0" algn="l">
               <a:buNone/>
             </a:pPr>
             <a:r>
@@ -4511,6 +4474,13 @@
             <a:prstDash val="solid"/>
           </a:ln>
         </p:spPr>
+        <p:txBody>
+          <a:bodyPr/>
+          <a:lstStyle/>
+          <a:p>
+            <a:endParaRPr lang="en-US"/>
+          </a:p>
+        </p:txBody>
       </p:sp>
       <p:sp>
         <p:nvSpPr>
@@ -4536,6 +4506,13 @@
             <a:prstDash val="solid"/>
           </a:ln>
         </p:spPr>
+        <p:txBody>
+          <a:bodyPr/>
+          <a:lstStyle/>
+          <a:p>
+            <a:endParaRPr lang="en-US"/>
+          </a:p>
+        </p:txBody>
       </p:sp>
       <p:sp>
         <p:nvSpPr>
@@ -4558,7 +4535,7 @@
           <a:bodyPr wrap="square" lIns="0" tIns="0" rIns="0" bIns="0" rtlCol="0" anchor="ctr"/>
           <a:lstStyle/>
           <a:p>
-            <a:pPr indent="0" marL="0">
+            <a:pPr marL="0" indent="0">
               <a:buNone/>
             </a:pPr>
             <a:r>
@@ -4625,7 +4602,7 @@
                   <a:schemeClr val="tx1"/>
                 </a:solidFill>
               </a:rPr>
-              <a:t>Evals: Haiku passed 4 of 9, Sonnet 9 of 9, so I use Sonnet</a:t>
+              <a:t>Evals: Haiku passed 4 of 9; Sonnet 6 to 9 of 9 across runs</a:t>
             </a:r>
             <a:endParaRPr lang="en-US" sz="1400" dirty="0"/>
           </a:p>
@@ -4675,6 +4652,13 @@
             <a:prstDash val="solid"/>
           </a:ln>
         </p:spPr>
+        <p:txBody>
+          <a:bodyPr/>
+          <a:lstStyle/>
+          <a:p>
+            <a:endParaRPr lang="en-US"/>
+          </a:p>
+        </p:txBody>
       </p:sp>
       <p:sp>
         <p:nvSpPr>
@@ -4700,6 +4684,13 @@
             <a:prstDash val="solid"/>
           </a:ln>
         </p:spPr>
+        <p:txBody>
+          <a:bodyPr/>
+          <a:lstStyle/>
+          <a:p>
+            <a:endParaRPr lang="en-US"/>
+          </a:p>
+        </p:txBody>
       </p:sp>
       <p:sp>
         <p:nvSpPr>
@@ -4722,7 +4713,7 @@
           <a:bodyPr wrap="square" lIns="0" tIns="0" rIns="0" bIns="0" rtlCol="0" anchor="ctr"/>
           <a:lstStyle/>
           <a:p>
-            <a:pPr indent="0" marL="0">
+            <a:pPr marL="0" indent="0">
               <a:buNone/>
             </a:pPr>
             <a:r>
@@ -4807,7 +4798,7 @@
                   <a:schemeClr val="tx1"/>
                 </a:solidFill>
               </a:rPr>
-              <a:t>Only 9 eval cases, which is a small sample</a:t>
+              <a:t>Eval scores vary from run to run</a:t>
             </a:r>
             <a:endParaRPr lang="en-US" sz="1400" dirty="0"/>
           </a:p>
@@ -4839,6 +4830,13 @@
             <a:prstDash val="solid"/>
           </a:ln>
         </p:spPr>
+        <p:txBody>
+          <a:bodyPr/>
+          <a:lstStyle/>
+          <a:p>
+            <a:endParaRPr lang="en-US"/>
+          </a:p>
+        </p:txBody>
       </p:sp>
       <p:sp>
         <p:nvSpPr>
@@ -4864,6 +4862,13 @@
             <a:prstDash val="solid"/>
           </a:ln>
         </p:spPr>
+        <p:txBody>
+          <a:bodyPr/>
+          <a:lstStyle/>
+          <a:p>
+            <a:endParaRPr lang="en-US"/>
+          </a:p>
+        </p:txBody>
       </p:sp>
       <p:sp>
         <p:nvSpPr>
@@ -4886,7 +4891,7 @@
           <a:bodyPr wrap="square" lIns="0" tIns="0" rIns="0" bIns="0" rtlCol="0" anchor="ctr"/>
           <a:lstStyle/>
           <a:p>
-            <a:pPr indent="0" marL="0">
+            <a:pPr marL="0" indent="0">
               <a:buNone/>
             </a:pPr>
             <a:r>
@@ -4997,7 +5002,7 @@
           </a:prstGeom>
           <a:extLst>
             <a:ext uri="{C572A759-6A51-4108-AA02-DFA0A04FC94B}">
-              <ma14:wrappingTextBoxFlag xmlns:ma14="http://schemas.microsoft.com/office/mac/drawingml/2011/main" val="0"/>
+              <ma14:wrappingTextBoxFlag xmlns:ma14="http://schemas.microsoft.com/office/mac/drawingml/2011/main" xmlns="" val="0"/>
             </a:ext>
           </a:extLst>
         </p:spPr>
@@ -5015,7 +5020,7 @@
           <a:p>
             <a:pPr algn="r"/>
             <a:fld id="{F7021451-1387-4CA6-816F-3879F97B5CBC}" type="slidenum">
-              <a:rPr b="0" lang="en-US"/>
+              <a:rPr lang="en-US" b="0"/>
               <a:t>6</a:t>
             </a:fld>
             <a:endParaRPr lang="en-US"/>
@@ -5323,4 +5328,319 @@
     </a:ext>
   </a:extLst>
 </a:theme>
+</file>
+
+<file path=ppt/theme/theme2.xml><?xml version="1.0" encoding="utf-8"?>
+<a:theme xmlns:a="http://schemas.openxmlformats.org/drawingml/2006/main" name="Office Theme">
+  <a:themeElements>
+    <a:clrScheme name="Office">
+      <a:dk1>
+        <a:sysClr val="windowText" lastClr="000000"/>
+      </a:dk1>
+      <a:lt1>
+        <a:sysClr val="window" lastClr="FFFFFF"/>
+      </a:lt1>
+      <a:dk2>
+        <a:srgbClr val="0E2841"/>
+      </a:dk2>
+      <a:lt2>
+        <a:srgbClr val="E8E8E8"/>
+      </a:lt2>
+      <a:accent1>
+        <a:srgbClr val="156082"/>
+      </a:accent1>
+      <a:accent2>
+        <a:srgbClr val="E97132"/>
+      </a:accent2>
+      <a:accent3>
+        <a:srgbClr val="196B24"/>
+      </a:accent3>
+      <a:accent4>
+        <a:srgbClr val="0F9ED5"/>
+      </a:accent4>
+      <a:accent5>
+        <a:srgbClr val="A02B93"/>
+      </a:accent5>
+      <a:accent6>
+        <a:srgbClr val="4EA72E"/>
+      </a:accent6>
+      <a:hlink>
+        <a:srgbClr val="467886"/>
+      </a:hlink>
+      <a:folHlink>
+        <a:srgbClr val="96607D"/>
+      </a:folHlink>
+    </a:clrScheme>
+    <a:fontScheme name="Office">
+      <a:majorFont>
+        <a:latin typeface="Aptos Display" panose="02110004020202020204"/>
+        <a:ea typeface=""/>
+        <a:cs typeface=""/>
+        <a:font script="Jpan" typeface="游ゴシック Light"/>
+        <a:font script="Hang" typeface="맑은 고딕"/>
+        <a:font script="Hans" typeface="等线 Light"/>
+        <a:font script="Hant" typeface="新細明體"/>
+        <a:font script="Arab" typeface="Times New Roman"/>
+        <a:font script="Hebr" typeface="Times New Roman"/>
+        <a:font script="Thai" typeface="Angsana New"/>
+        <a:font script="Ethi" typeface="Nyala"/>
+        <a:font script="Beng" typeface="Vrinda"/>
+        <a:font script="Gujr" typeface="Shruti"/>
+        <a:font script="Khmr" typeface="MoolBoran"/>
+        <a:font script="Knda" typeface="Tunga"/>
+        <a:font script="Guru" typeface="Raavi"/>
+        <a:font script="Cans" typeface="Euphemia"/>
+        <a:font script="Cher" typeface="Plantagenet Cherokee"/>
+        <a:font script="Yiii" typeface="Microsoft Yi Baiti"/>
+        <a:font script="Tibt" typeface="Microsoft Himalaya"/>
+        <a:font script="Thaa" typeface="MV Boli"/>
+        <a:font script="Deva" typeface="Mangal"/>
+        <a:font script="Telu" typeface="Gautami"/>
+        <a:font script="Taml" typeface="Latha"/>
+        <a:font script="Syrc" typeface="Estrangelo Edessa"/>
+        <a:font script="Orya" typeface="Kalinga"/>
+        <a:font script="Mlym" typeface="Kartika"/>
+        <a:font script="Laoo" typeface="DokChampa"/>
+        <a:font script="Sinh" typeface="Iskoola Pota"/>
+        <a:font script="Mong" typeface="Mongolian Baiti"/>
+        <a:font script="Viet" typeface="Times New Roman"/>
+        <a:font script="Uigh" typeface="Microsoft Uighur"/>
+        <a:font script="Geor" typeface="Sylfaen"/>
+        <a:font script="Armn" typeface="Arial"/>
+        <a:font script="Bugi" typeface="Leelawadee UI"/>
+        <a:font script="Bopo" typeface="Microsoft JhengHei"/>
+        <a:font script="Java" typeface="Javanese Text"/>
+        <a:font script="Lisu" typeface="Segoe UI"/>
+        <a:font script="Mymr" typeface="Myanmar Text"/>
+        <a:font script="Nkoo" typeface="Ebrima"/>
+        <a:font script="Olck" typeface="Nirmala UI"/>
+        <a:font script="Osma" typeface="Ebrima"/>
+        <a:font script="Phag" typeface="Phagspa"/>
+        <a:font script="Syrn" typeface="Estrangelo Edessa"/>
+        <a:font script="Syrj" typeface="Estrangelo Edessa"/>
+        <a:font script="Syre" typeface="Estrangelo Edessa"/>
+        <a:font script="Sora" typeface="Nirmala UI"/>
+        <a:font script="Tale" typeface="Microsoft Tai Le"/>
+        <a:font script="Talu" typeface="Microsoft New Tai Lue"/>
+        <a:font script="Tfng" typeface="Ebrima"/>
+      </a:majorFont>
+      <a:minorFont>
+        <a:latin typeface="Aptos" panose="02110004020202020204"/>
+        <a:ea typeface=""/>
+        <a:cs typeface=""/>
+        <a:font script="Jpan" typeface="游ゴシック"/>
+        <a:font script="Hang" typeface="맑은 고딕"/>
+        <a:font script="Hans" typeface="等线"/>
+        <a:font script="Hant" typeface="新細明體"/>
+        <a:font script="Arab" typeface="Arial"/>
+        <a:font script="Hebr" typeface="Arial"/>
+        <a:font script="Thai" typeface="Cordia New"/>
+        <a:font script="Ethi" typeface="Nyala"/>
+        <a:font script="Beng" typeface="Vrinda"/>
+        <a:font script="Gujr" typeface="Shruti"/>
+        <a:font script="Khmr" typeface="DaunPenh"/>
+        <a:font script="Knda" typeface="Tunga"/>
+        <a:font script="Guru" typeface="Raavi"/>
+        <a:font script="Cans" typeface="Euphemia"/>
+        <a:font script="Cher" typeface="Plantagenet Cherokee"/>
+        <a:font script="Yiii" typeface="Microsoft Yi Baiti"/>
+        <a:font script="Tibt" typeface="Microsoft Himalaya"/>
+        <a:font script="Thaa" typeface="MV Boli"/>
+        <a:font script="Deva" typeface="Mangal"/>
+        <a:font script="Telu" typeface="Gautami"/>
+        <a:font script="Taml" typeface="Latha"/>
+        <a:font script="Syrc" typeface="Estrangelo Edessa"/>
+        <a:font script="Orya" typeface="Kalinga"/>
+        <a:font script="Mlym" typeface="Kartika"/>
+        <a:font script="Laoo" typeface="DokChampa"/>
+        <a:font script="Sinh" typeface="Iskoola Pota"/>
+        <a:font script="Mong" typeface="Mongolian Baiti"/>
+        <a:font script="Viet" typeface="Arial"/>
+        <a:font script="Uigh" typeface="Microsoft Uighur"/>
+        <a:font script="Geor" typeface="Sylfaen"/>
+        <a:font script="Armn" typeface="Arial"/>
+        <a:font script="Bugi" typeface="Leelawadee UI"/>
+        <a:font script="Bopo" typeface="Microsoft JhengHei"/>
+        <a:font script="Java" typeface="Javanese Text"/>
+        <a:font script="Lisu" typeface="Segoe UI"/>
+        <a:font script="Mymr" typeface="Myanmar Text"/>
+        <a:font script="Nkoo" typeface="Ebrima"/>
+        <a:font script="Olck" typeface="Nirmala UI"/>
+        <a:font script="Osma" typeface="Ebrima"/>
+        <a:font script="Phag" typeface="Phagspa"/>
+        <a:font script="Syrn" typeface="Estrangelo Edessa"/>
+        <a:font script="Syrj" typeface="Estrangelo Edessa"/>
+        <a:font script="Syre" typeface="Estrangelo Edessa"/>
+        <a:font script="Sora" typeface="Nirmala UI"/>
+        <a:font script="Tale" typeface="Microsoft Tai Le"/>
+        <a:font script="Talu" typeface="Microsoft New Tai Lue"/>
+        <a:font script="Tfng" typeface="Ebrima"/>
+      </a:minorFont>
+    </a:fontScheme>
+    <a:fmtScheme name="Office">
+      <a:fillStyleLst>
+        <a:solidFill>
+          <a:schemeClr val="phClr"/>
+        </a:solidFill>
+        <a:gradFill rotWithShape="1">
+          <a:gsLst>
+            <a:gs pos="0">
+              <a:schemeClr val="phClr">
+                <a:lumMod val="110000"/>
+                <a:satMod val="105000"/>
+                <a:tint val="67000"/>
+              </a:schemeClr>
+            </a:gs>
+            <a:gs pos="50000">
+              <a:schemeClr val="phClr">
+                <a:lumMod val="105000"/>
+                <a:satMod val="103000"/>
+                <a:tint val="73000"/>
+              </a:schemeClr>
+            </a:gs>
+            <a:gs pos="100000">
+              <a:schemeClr val="phClr">
+                <a:lumMod val="105000"/>
+                <a:satMod val="109000"/>
+                <a:tint val="81000"/>
+              </a:schemeClr>
+            </a:gs>
+          </a:gsLst>
+          <a:lin ang="5400000" scaled="0"/>
+        </a:gradFill>
+        <a:gradFill rotWithShape="1">
+          <a:gsLst>
+            <a:gs pos="0">
+              <a:schemeClr val="phClr">
+                <a:satMod val="103000"/>
+                <a:lumMod val="102000"/>
+                <a:tint val="94000"/>
+              </a:schemeClr>
+            </a:gs>
+            <a:gs pos="50000">
+              <a:schemeClr val="phClr">
+                <a:satMod val="110000"/>
+                <a:lumMod val="100000"/>
+                <a:shade val="100000"/>
+              </a:schemeClr>
+            </a:gs>
+            <a:gs pos="100000">
+              <a:schemeClr val="phClr">
+                <a:lumMod val="99000"/>
+                <a:satMod val="120000"/>
+                <a:shade val="78000"/>
+              </a:schemeClr>
+            </a:gs>
+          </a:gsLst>
+          <a:lin ang="5400000" scaled="0"/>
+        </a:gradFill>
+      </a:fillStyleLst>
+      <a:lnStyleLst>
+        <a:ln w="12700" cap="flat" cmpd="sng" algn="ctr">
+          <a:solidFill>
+            <a:schemeClr val="phClr"/>
+          </a:solidFill>
+          <a:prstDash val="solid"/>
+          <a:miter lim="800000"/>
+        </a:ln>
+        <a:ln w="19050" cap="flat" cmpd="sng" algn="ctr">
+          <a:solidFill>
+            <a:schemeClr val="phClr"/>
+          </a:solidFill>
+          <a:prstDash val="solid"/>
+          <a:miter lim="800000"/>
+        </a:ln>
+        <a:ln w="25400" cap="flat" cmpd="sng" algn="ctr">
+          <a:solidFill>
+            <a:schemeClr val="phClr"/>
+          </a:solidFill>
+          <a:prstDash val="solid"/>
+          <a:miter lim="800000"/>
+        </a:ln>
+      </a:lnStyleLst>
+      <a:effectStyleLst>
+        <a:effectStyle>
+          <a:effectLst/>
+        </a:effectStyle>
+        <a:effectStyle>
+          <a:effectLst/>
+        </a:effectStyle>
+        <a:effectStyle>
+          <a:effectLst>
+            <a:outerShdw blurRad="57150" dist="19050" dir="5400000" algn="ctr" rotWithShape="0">
+              <a:srgbClr val="000000">
+                <a:alpha val="63000"/>
+              </a:srgbClr>
+            </a:outerShdw>
+          </a:effectLst>
+        </a:effectStyle>
+      </a:effectStyleLst>
+      <a:bgFillStyleLst>
+        <a:solidFill>
+          <a:schemeClr val="phClr"/>
+        </a:solidFill>
+        <a:solidFill>
+          <a:schemeClr val="phClr">
+            <a:tint val="95000"/>
+            <a:satMod val="170000"/>
+          </a:schemeClr>
+        </a:solidFill>
+        <a:gradFill rotWithShape="1">
+          <a:gsLst>
+            <a:gs pos="0">
+              <a:schemeClr val="phClr">
+                <a:tint val="93000"/>
+                <a:satMod val="150000"/>
+                <a:shade val="98000"/>
+                <a:lumMod val="102000"/>
+              </a:schemeClr>
+            </a:gs>
+            <a:gs pos="50000">
+              <a:schemeClr val="phClr">
+                <a:tint val="98000"/>
+                <a:satMod val="130000"/>
+                <a:shade val="90000"/>
+                <a:lumMod val="103000"/>
+              </a:schemeClr>
+            </a:gs>
+            <a:gs pos="100000">
+              <a:schemeClr val="phClr">
+                <a:shade val="63000"/>
+                <a:satMod val="120000"/>
+              </a:schemeClr>
+            </a:gs>
+          </a:gsLst>
+          <a:lin ang="5400000" scaled="0"/>
+        </a:gradFill>
+      </a:bgFillStyleLst>
+    </a:fmtScheme>
+  </a:themeElements>
+  <a:objectDefaults>
+    <a:lnDef>
+      <a:spPr/>
+      <a:bodyPr/>
+      <a:lstStyle/>
+      <a:style>
+        <a:lnRef idx="2">
+          <a:schemeClr val="accent1"/>
+        </a:lnRef>
+        <a:fillRef idx="0">
+          <a:schemeClr val="accent1"/>
+        </a:fillRef>
+        <a:effectRef idx="1">
+          <a:schemeClr val="accent1"/>
+        </a:effectRef>
+        <a:fontRef idx="minor">
+          <a:schemeClr val="tx1"/>
+        </a:fontRef>
+      </a:style>
+    </a:lnDef>
+  </a:objectDefaults>
+  <a:extraClrSchemeLst/>
+  <a:extLst>
+    <a:ext uri="{05A4C25C-085E-4340-85A3-A5531E510DB2}">
+      <thm15:themeFamily xmlns:thm15="http://schemas.microsoft.com/office/thememl/2012/main" name="Office Theme" id="{2E142A2C-CD16-42D6-873A-C26D2A0506FA}" vid="{1BDDFF52-6CD6-40A5-AB3C-68EB2F1E4D0A}"/>
+    </a:ext>
+  </a:extLst>
+</a:theme>
 </file>
</xml_diff>